<commit_message>
docs(#71): capture live v1.1.0 screenshots for the academic pack
Fold Pages v1.1.0 member shots 1-14, wiki Mermaid 17-18, and VPS
health 19 into the report PDF and defense deck. Admin 15-16 stay
blocked on staff bootstrap (#78). Cookie line matches live
SameSite=None; Partitioned.

Refs: Projet-de-compensation-2025-2026/gym-buddy-documentation#71
</commit_message>
<xml_diff>
--- a/99-Academic-deliverables/Gym-Buddies-defense.pptx
+++ b/99-Academic-deliverables/Gym-Buddies-defense.pptx
@@ -600,10 +600,8 @@
           <a:lstStyle/>
           <a:p>
             <a:r>
-              <a:rPr lang="en-US" dirty="0"/>
-              <a:t>Stranger cannot fetch an object key. TS-JWT, FS-MED-06/07.</a:t>
-            </a:r>
-            <a:endParaRPr lang="en-US" dirty="0"/>
+              <a:t>Live 1.1.0 cookie is SameSite=None; Partitioned so github.io can send it. SameSite=Lax was the v1.0.0 session-drop. Stranger cannot fetch an object key. TS-JWT, FS-MED-06/07.</a:t>
+            </a:r>
           </a:p>
         </p:txBody>
       </p:sp>
@@ -1040,10 +1038,8 @@
           <a:lstStyle/>
           <a:p>
             <a:r>
-              <a:rPr lang="en-US" dirty="0"/>
-              <a:t>Live as demo.alex. FS-FEED, FS-POST, FS-CMT, FS-FRND.</a:t>
-            </a:r>
-            <a:endParaRPr lang="en-US" dirty="0"/>
+              <a:t>Live v1.1.0 as registered members; demo.alex password is not in git. FS-FEED, FS-POST, FS-CMT, FS-FRND.</a:t>
+            </a:r>
           </a:p>
         </p:txBody>
       </p:sp>
@@ -1128,10 +1124,8 @@
           <a:lstStyle/>
           <a:p>
             <a:r>
-              <a:rPr lang="en-US" dirty="0"/>
-              <a:t>Show a full event and a rejected extra applicant. SELECT FOR UPDATE.</a:t>
-            </a:r>
-            <a:endParaRPr lang="en-US" dirty="0"/>
+              <a:t>Show a full event and a rejected extra applicant. SELECT FOR UPDATE. Live capture: capacity 1, Blake pending then Full.</a:t>
+            </a:r>
           </a:p>
         </p:txBody>
       </p:sp>
@@ -1216,10 +1210,8 @@
           <a:lstStyle/>
           <a:p>
             <a:r>
-              <a:rPr lang="en-US" dirty="0"/>
-              <a:t>Read the why line on a suggestion card. FS-SUGG-03, FS-MSG.</a:t>
-            </a:r>
-            <a:endParaRPr lang="en-US" dirty="0"/>
+              <a:t>Read the why line when a card exists. Live prod suggestions were empty (no 3k fixtures). Chat text works; image/audio need object storage. FS-SUGG-03, FS-MSG.</a:t>
+            </a:r>
           </a:p>
         </p:txBody>
       </p:sp>
@@ -1878,6 +1870,10 @@
             <a:prstDash val="solid"/>
           </a:ln>
         </p:spPr>
+        <p:txBody>
+          <a:bodyPr/>
+          <a:p/>
+        </p:txBody>
       </p:sp>
       <p:sp>
         <p:nvSpPr>
@@ -2029,7 +2025,7 @@
                 <a:ea typeface="Calibri" pitchFamily="34" charset="-122"/>
                 <a:cs typeface="Calibri" pitchFamily="34" charset="-120"/>
               </a:rPr>
-              <a:t>Joaquim Kéloglanian  ·  20 min + 30 min Q&amp;A  ·  wiki commit 2fcabfa</a:t>
+              <a:t>Joaquim Kéloglanian  ·  20 min + 30 min Q&amp;A  ·  wiki ab679f9+#71</a:t>
             </a:r>
             <a:endParaRPr lang="en-US" sz="1400" dirty="0"/>
           </a:p>
@@ -2091,6 +2087,10 @@
             <a:prstDash val="solid"/>
           </a:ln>
         </p:spPr>
+        <p:txBody>
+          <a:bodyPr/>
+          <a:p/>
+        </p:txBody>
       </p:sp>
       <p:sp>
         <p:nvSpPr>
@@ -2320,7 +2320,7 @@
                 <a:ea typeface="Calibri" pitchFamily="34" charset="-122"/>
                 <a:cs typeface="Calibri" pitchFamily="34" charset="-120"/>
               </a:rPr>
-              <a:t>HS256 access in JSON. Refresh cookie HttpOnly + Secure + SameSite=Lax. Redis denylist.</a:t>
+              <a:t>HS256 access in JSON. Refresh cookie HttpOnly + Secure + SameSite=None; Partitioned. Redis denylist.</a:t>
             </a:r>
             <a:endParaRPr lang="en-US" sz="1600" dirty="0"/>
           </a:p>
@@ -3180,6 +3180,10 @@
             <a:prstDash val="solid"/>
           </a:ln>
         </p:spPr>
+        <p:txBody>
+          <a:bodyPr/>
+          <a:p/>
+        </p:txBody>
       </p:sp>
       <p:sp>
         <p:nvSpPr>
@@ -3437,7 +3441,7 @@
                 <a:ea typeface="Calibri" pitchFamily="34" charset="-122"/>
                 <a:cs typeface="Calibri" pitchFamily="34" charset="-120"/>
               </a:rPr>
-              <a:t>Live Pages login from the public internet (UFW + SameSite=Lax).</a:t>
+              <a:t>Staff bootstrap + MinIO on the VPS (admin 15–16 and signed media).</a:t>
             </a:r>
             <a:endParaRPr lang="en-US" sz="1800" dirty="0"/>
           </a:p>
@@ -4687,6 +4691,10 @@
             <a:prstDash val="solid"/>
           </a:ln>
         </p:spPr>
+        <p:txBody>
+          <a:bodyPr/>
+          <a:p/>
+        </p:txBody>
       </p:sp>
       <p:sp>
         <p:nvSpPr>
@@ -4760,7 +4768,7 @@
                 <a:ea typeface="Calibri" pitchFamily="34" charset="-122"/>
                 <a:cs typeface="Calibri" pitchFamily="34" charset="-120"/>
               </a:rPr>
-              <a:t>Demo 1 · social  ·  live as demo.alex</a:t>
+              <a:t>Demo 1 · social  ·  live v1.1.0</a:t>
             </a:r>
             <a:endParaRPr lang="en-US" sz="1000" dirty="0"/>
           </a:p>
@@ -4955,7 +4963,7 @@
                 <a:ea typeface="Calibri" pitchFamily="34" charset="-122"/>
                 <a:cs typeface="Calibri" pitchFamily="34" charset="-120"/>
               </a:rPr>
-              <a:t>demo.alex from .env</a:t>
+              <a:t>fresh register on Pages</a:t>
             </a:r>
             <a:endParaRPr lang="en-US" sz="1400" dirty="0"/>
           </a:p>
@@ -5437,8 +5445,8 @@
         </p:nvSpPr>
         <p:spPr>
           <a:xfrm>
-            <a:off x="731520" y="4206240"/>
-            <a:ext cx="10698480" cy="365760"/>
+            <a:off x="731520" y="3566160"/>
+            <a:ext cx="10698480" cy="256032"/>
           </a:xfrm>
           <a:prstGeom prst="rect">
             <a:avLst/>
@@ -5462,12 +5470,84 @@
                 <a:ea typeface="Calibri" pitchFamily="34" charset="-122"/>
                 <a:cs typeface="Calibri" pitchFamily="34" charset="-120"/>
               </a:rPr>
-              <a:t>If the live app fails, play the offline recording. Do not invent a story.</a:t>
+              <a:t>Live Pages v1.1.0, 2026-08-31 — not mockups.</a:t>
             </a:r>
             <a:endParaRPr lang="en-US" sz="1600" dirty="0"/>
           </a:p>
         </p:txBody>
       </p:sp>
+      <p:pic>
+        <p:nvPicPr>
+          <p:cNvPr id="23" name="Picture 22" descr="01-register-login.png"/>
+          <p:cNvPicPr>
+            <a:picLocks noChangeAspect="1"/>
+          </p:cNvPicPr>
+          <p:nvPr/>
+        </p:nvPicPr>
+        <p:blipFill>
+          <a:blip r:embed="rId3"/>
+          <a:stretch>
+            <a:fillRect/>
+          </a:stretch>
+        </p:blipFill>
+        <p:spPr>
+          <a:xfrm>
+            <a:off x="731520" y="3858768"/>
+            <a:ext cx="3305907" cy="2148840"/>
+          </a:xfrm>
+          <a:prstGeom prst="rect">
+            <a:avLst/>
+          </a:prstGeom>
+        </p:spPr>
+      </p:pic>
+      <p:pic>
+        <p:nvPicPr>
+          <p:cNvPr id="24" name="Picture 23" descr="05-friends-feed-post-repost.png"/>
+          <p:cNvPicPr>
+            <a:picLocks noChangeAspect="1"/>
+          </p:cNvPicPr>
+          <p:nvPr/>
+        </p:nvPicPr>
+        <p:blipFill>
+          <a:blip r:embed="rId4"/>
+          <a:stretch>
+            <a:fillRect/>
+          </a:stretch>
+        </p:blipFill>
+        <p:spPr>
+          <a:xfrm>
+            <a:off x="4297680" y="3858768"/>
+            <a:ext cx="3297979" cy="2148840"/>
+          </a:xfrm>
+          <a:prstGeom prst="rect">
+            <a:avLst/>
+          </a:prstGeom>
+        </p:spPr>
+      </p:pic>
+      <p:pic>
+        <p:nvPicPr>
+          <p:cNvPr id="25" name="Picture 24" descr="07-comment-thread.png"/>
+          <p:cNvPicPr>
+            <a:picLocks noChangeAspect="1"/>
+          </p:cNvPicPr>
+          <p:nvPr/>
+        </p:nvPicPr>
+        <p:blipFill>
+          <a:blip r:embed="rId5"/>
+          <a:stretch>
+            <a:fillRect/>
+          </a:stretch>
+        </p:blipFill>
+        <p:spPr>
+          <a:xfrm>
+            <a:off x="7863840" y="3858768"/>
+            <a:ext cx="3097427" cy="2148840"/>
+          </a:xfrm>
+          <a:prstGeom prst="rect">
+            <a:avLst/>
+          </a:prstGeom>
+        </p:spPr>
+      </p:pic>
     </p:spTree>
   </p:cSld>
   <p:clrMapOvr>
@@ -5524,6 +5604,10 @@
             <a:prstDash val="solid"/>
           </a:ln>
         </p:spPr>
+        <p:txBody>
+          <a:bodyPr/>
+          <a:p/>
+        </p:txBody>
       </p:sp>
       <p:sp>
         <p:nvSpPr>
@@ -6706,6 +6790,54 @@
           </a:graphicData>
         </a:graphic>
       </p:graphicFrame>
+      <p:pic>
+        <p:nvPicPr>
+          <p:cNvPr id="7" name="Picture 6" descr="08-friends-only-event.png"/>
+          <p:cNvPicPr>
+            <a:picLocks noChangeAspect="1"/>
+          </p:cNvPicPr>
+          <p:nvPr/>
+        </p:nvPicPr>
+        <p:blipFill>
+          <a:blip r:embed="rId3"/>
+          <a:stretch>
+            <a:fillRect/>
+          </a:stretch>
+        </p:blipFill>
+        <p:spPr>
+          <a:xfrm>
+            <a:off x="731520" y="3794760"/>
+            <a:ext cx="3172077" cy="2240280"/>
+          </a:xfrm>
+          <a:prstGeom prst="rect">
+            <a:avLst/>
+          </a:prstGeom>
+        </p:spPr>
+      </p:pic>
+      <p:pic>
+        <p:nvPicPr>
+          <p:cNvPr id="8" name="Picture 7" descr="09-event-applications.png"/>
+          <p:cNvPicPr>
+            <a:picLocks noChangeAspect="1"/>
+          </p:cNvPicPr>
+          <p:nvPr/>
+        </p:nvPicPr>
+        <p:blipFill>
+          <a:blip r:embed="rId4"/>
+          <a:stretch>
+            <a:fillRect/>
+          </a:stretch>
+        </p:blipFill>
+        <p:spPr>
+          <a:xfrm>
+            <a:off x="6263640" y="3794760"/>
+            <a:ext cx="3584448" cy="2240280"/>
+          </a:xfrm>
+          <a:prstGeom prst="rect">
+            <a:avLst/>
+          </a:prstGeom>
+        </p:spPr>
+      </p:pic>
     </p:spTree>
   </p:cSld>
   <p:clrMapOvr>
@@ -6762,6 +6894,10 @@
             <a:prstDash val="solid"/>
           </a:ln>
         </p:spPr>
+        <p:txBody>
+          <a:bodyPr/>
+          <a:p/>
+        </p:txBody>
       </p:sp>
       <p:sp>
         <p:nvSpPr>
@@ -6928,7 +7064,7 @@
         <p:spPr>
           <a:xfrm>
             <a:off x="731520" y="1828800"/>
-            <a:ext cx="5120640" cy="3291840"/>
+            <a:ext cx="5120640" cy="1783080"/>
           </a:xfrm>
           <a:prstGeom prst="rect">
             <a:avLst/>
@@ -6943,6 +7079,10 @@
             <a:prstDash val="solid"/>
           </a:ln>
         </p:spPr>
+        <p:txBody>
+          <a:bodyPr/>
+          <a:p/>
+        </p:txBody>
       </p:sp>
       <p:sp>
         <p:nvSpPr>
@@ -6992,7 +7132,7 @@
         <p:spPr>
           <a:xfrm>
             <a:off x="1051560" y="2514600"/>
-            <a:ext cx="4572000" cy="2194560"/>
+            <a:ext cx="4572000" cy="960120"/>
           </a:xfrm>
           <a:prstGeom prst="rect">
             <a:avLst/>
@@ -7031,7 +7171,7 @@
         <p:spPr>
           <a:xfrm>
             <a:off x="6217920" y="1828800"/>
-            <a:ext cx="5212080" cy="3291840"/>
+            <a:ext cx="5212080" cy="1783080"/>
           </a:xfrm>
           <a:prstGeom prst="rect">
             <a:avLst/>
@@ -7046,6 +7186,10 @@
             <a:prstDash val="solid"/>
           </a:ln>
         </p:spPr>
+        <p:txBody>
+          <a:bodyPr/>
+          <a:p/>
+        </p:txBody>
       </p:sp>
       <p:sp>
         <p:nvSpPr>
@@ -7095,7 +7239,7 @@
         <p:spPr>
           <a:xfrm>
             <a:off x="6537960" y="2514600"/>
-            <a:ext cx="4663440" cy="2194560"/>
+            <a:ext cx="4663440" cy="960120"/>
           </a:xfrm>
           <a:prstGeom prst="rect">
             <a:avLst/>
@@ -7125,6 +7269,54 @@
           </a:p>
         </p:txBody>
       </p:sp>
+      <p:pic>
+        <p:nvPicPr>
+          <p:cNvPr id="13" name="Picture 12" descr="12-suggestions-why.png"/>
+          <p:cNvPicPr>
+            <a:picLocks noChangeAspect="1"/>
+          </p:cNvPicPr>
+          <p:nvPr/>
+        </p:nvPicPr>
+        <p:blipFill>
+          <a:blip r:embed="rId3"/>
+          <a:stretch>
+            <a:fillRect/>
+          </a:stretch>
+        </p:blipFill>
+        <p:spPr>
+          <a:xfrm>
+            <a:off x="731520" y="3794760"/>
+            <a:ext cx="3511296" cy="2194560"/>
+          </a:xfrm>
+          <a:prstGeom prst="rect">
+            <a:avLst/>
+          </a:prstGeom>
+        </p:spPr>
+      </p:pic>
+      <p:pic>
+        <p:nvPicPr>
+          <p:cNvPr id="14" name="Picture 13" descr="13-chat-text-image-audio.png"/>
+          <p:cNvPicPr>
+            <a:picLocks noChangeAspect="1"/>
+          </p:cNvPicPr>
+          <p:nvPr/>
+        </p:nvPicPr>
+        <p:blipFill>
+          <a:blip r:embed="rId4"/>
+          <a:stretch>
+            <a:fillRect/>
+          </a:stretch>
+        </p:blipFill>
+        <p:spPr>
+          <a:xfrm>
+            <a:off x="6217920" y="3794760"/>
+            <a:ext cx="3511296" cy="2194560"/>
+          </a:xfrm>
+          <a:prstGeom prst="rect">
+            <a:avLst/>
+          </a:prstGeom>
+        </p:spPr>
+      </p:pic>
     </p:spTree>
   </p:cSld>
   <p:clrMapOvr>

</xml_diff>